<commit_message>
Add impact of padding images
</commit_message>
<xml_diff>
--- a/mydocuments/Examining The Effect of Padding on Facial Recognition.pptx
+++ b/mydocuments/Examining The Effect of Padding on Facial Recognition.pptx
@@ -5,7 +5,7 @@
     <p:sldMasterId id="2147483725" r:id="rId1"/>
   </p:sldMasterIdLst>
   <p:notesMasterIdLst>
-    <p:notesMasterId r:id="rId42"/>
+    <p:notesMasterId r:id="rId41"/>
   </p:notesMasterIdLst>
   <p:sldIdLst>
     <p:sldId id="256" r:id="rId2"/>
@@ -46,8 +46,7 @@
     <p:sldId id="297" r:id="rId37"/>
     <p:sldId id="287" r:id="rId38"/>
     <p:sldId id="288" r:id="rId39"/>
-    <p:sldId id="289" r:id="rId40"/>
-    <p:sldId id="290" r:id="rId41"/>
+    <p:sldId id="298" r:id="rId40"/>
   </p:sldIdLst>
   <p:sldSz cx="12192000" cy="6858000"/>
   <p:notesSz cx="6858000" cy="9144000"/>
@@ -236,7 +235,7 @@
           <a:p>
             <a:fld id="{292E59CD-D302-4A12-BB77-0F0A1F6B8C2A}" type="datetimeFigureOut">
               <a:rPr lang="en-KE" smtClean="0"/>
-              <a:t>03/24/2026</a:t>
+              <a:t>03/25/2026</a:t>
             </a:fld>
             <a:endParaRPr lang="en-KE"/>
           </a:p>
@@ -690,7 +689,7 @@
           <a:p>
             <a:fld id="{3449C556-1259-4C79-A42E-0A9380D1E073}" type="datetime8">
               <a:rPr lang="en-KE" smtClean="0"/>
-              <a:t>03/24/2026 12:03</a:t>
+              <a:t>03/25/2026 08:59</a:t>
             </a:fld>
             <a:endParaRPr lang="en-KE"/>
           </a:p>
@@ -965,7 +964,7 @@
           <a:p>
             <a:fld id="{5313799B-003D-4E1C-A5A0-25EACE4B1777}" type="datetime8">
               <a:rPr lang="en-KE" smtClean="0"/>
-              <a:t>03/24/2026 12:03</a:t>
+              <a:t>03/25/2026 08:59</a:t>
             </a:fld>
             <a:endParaRPr lang="en-KE"/>
           </a:p>
@@ -1160,7 +1159,7 @@
           <a:p>
             <a:fld id="{5313799B-003D-4E1C-A5A0-25EACE4B1777}" type="datetime8">
               <a:rPr lang="en-KE" smtClean="0"/>
-              <a:t>03/24/2026 12:03</a:t>
+              <a:t>03/25/2026 08:59</a:t>
             </a:fld>
             <a:endParaRPr lang="en-KE"/>
           </a:p>
@@ -1434,7 +1433,7 @@
           <a:p>
             <a:fld id="{5313799B-003D-4E1C-A5A0-25EACE4B1777}" type="datetime8">
               <a:rPr lang="en-KE" smtClean="0"/>
-              <a:t>03/24/2026 12:03</a:t>
+              <a:t>03/25/2026 08:59</a:t>
             </a:fld>
             <a:endParaRPr lang="en-KE"/>
           </a:p>
@@ -1776,7 +1775,7 @@
           <a:p>
             <a:fld id="{5313799B-003D-4E1C-A5A0-25EACE4B1777}" type="datetime8">
               <a:rPr lang="en-KE" smtClean="0"/>
-              <a:t>03/24/2026 12:03</a:t>
+              <a:t>03/25/2026 08:59</a:t>
             </a:fld>
             <a:endParaRPr lang="en-KE"/>
           </a:p>
@@ -2400,7 +2399,7 @@
           <a:p>
             <a:fld id="{5313799B-003D-4E1C-A5A0-25EACE4B1777}" type="datetime8">
               <a:rPr lang="en-KE" smtClean="0"/>
-              <a:t>03/24/2026 12:03</a:t>
+              <a:t>03/25/2026 08:59</a:t>
             </a:fld>
             <a:endParaRPr lang="en-KE"/>
           </a:p>
@@ -3261,7 +3260,7 @@
           <a:p>
             <a:fld id="{5313799B-003D-4E1C-A5A0-25EACE4B1777}" type="datetime8">
               <a:rPr lang="en-KE" smtClean="0"/>
-              <a:t>03/24/2026 12:03</a:t>
+              <a:t>03/25/2026 08:59</a:t>
             </a:fld>
             <a:endParaRPr lang="en-KE"/>
           </a:p>
@@ -3432,7 +3431,7 @@
           <a:p>
             <a:fld id="{B2FE7FE8-B144-4B40-B5EE-0BAE426496A2}" type="datetime8">
               <a:rPr lang="en-KE" smtClean="0"/>
-              <a:t>03/24/2026 12:03</a:t>
+              <a:t>03/25/2026 08:59</a:t>
             </a:fld>
             <a:endParaRPr lang="en-KE"/>
           </a:p>
@@ -3612,7 +3611,7 @@
           <a:p>
             <a:fld id="{2B872810-A43E-4DD9-86A8-0465EED572D9}" type="datetime8">
               <a:rPr lang="en-KE" smtClean="0"/>
-              <a:t>03/24/2026 12:03</a:t>
+              <a:t>03/25/2026 08:59</a:t>
             </a:fld>
             <a:endParaRPr lang="en-KE"/>
           </a:p>
@@ -3782,7 +3781,7 @@
           <a:p>
             <a:fld id="{1437B900-290F-4C0E-AD92-87EC28111150}" type="datetime8">
               <a:rPr lang="en-KE" smtClean="0"/>
-              <a:t>03/24/2026 12:03</a:t>
+              <a:t>03/25/2026 08:59</a:t>
             </a:fld>
             <a:endParaRPr lang="en-KE"/>
           </a:p>
@@ -4029,7 +4028,7 @@
           <a:p>
             <a:fld id="{D432375C-A9C4-43A7-8211-CB421FD0ED21}" type="datetime8">
               <a:rPr lang="en-KE" smtClean="0"/>
-              <a:t>03/24/2026 12:03</a:t>
+              <a:t>03/25/2026 08:59</a:t>
             </a:fld>
             <a:endParaRPr lang="en-KE"/>
           </a:p>
@@ -4321,7 +4320,7 @@
           <a:p>
             <a:fld id="{129D9306-E245-4416-B1AA-1EBC159225DC}" type="datetime8">
               <a:rPr lang="en-KE" smtClean="0"/>
-              <a:t>03/24/2026 12:03</a:t>
+              <a:t>03/25/2026 08:59</a:t>
             </a:fld>
             <a:endParaRPr lang="en-KE"/>
           </a:p>
@@ -4765,7 +4764,7 @@
           <a:p>
             <a:fld id="{DC70A33B-5B63-48CB-94FF-D1E092689D8F}" type="datetime8">
               <a:rPr lang="en-KE" smtClean="0"/>
-              <a:t>03/24/2026 12:03</a:t>
+              <a:t>03/25/2026 08:59</a:t>
             </a:fld>
             <a:endParaRPr lang="en-KE"/>
           </a:p>
@@ -4883,7 +4882,7 @@
           <a:p>
             <a:fld id="{1658D1E7-2FDC-47B5-B892-B64740E1ACD2}" type="datetime8">
               <a:rPr lang="en-KE" smtClean="0"/>
-              <a:t>03/24/2026 12:03</a:t>
+              <a:t>03/25/2026 08:59</a:t>
             </a:fld>
             <a:endParaRPr lang="en-KE"/>
           </a:p>
@@ -4978,7 +4977,7 @@
           <a:p>
             <a:fld id="{D8482E56-3814-4235-82BB-19DE0696C0D4}" type="datetime8">
               <a:rPr lang="en-KE" smtClean="0"/>
-              <a:t>03/24/2026 12:03</a:t>
+              <a:t>03/25/2026 08:59</a:t>
             </a:fld>
             <a:endParaRPr lang="en-KE"/>
           </a:p>
@@ -5257,7 +5256,7 @@
           <a:p>
             <a:fld id="{83F9CE03-FDFB-4ABA-B227-F406A6E9A989}" type="datetime8">
               <a:rPr lang="en-KE" smtClean="0"/>
-              <a:t>03/24/2026 12:03</a:t>
+              <a:t>03/25/2026 08:59</a:t>
             </a:fld>
             <a:endParaRPr lang="en-KE"/>
           </a:p>
@@ -5532,7 +5531,7 @@
           <a:p>
             <a:fld id="{436A4A10-04BD-4C6C-BB24-38008A86F711}" type="datetime8">
               <a:rPr lang="en-KE" smtClean="0"/>
-              <a:t>03/24/2026 12:03</a:t>
+              <a:t>03/25/2026 08:59</a:t>
             </a:fld>
             <a:endParaRPr lang="en-KE"/>
           </a:p>
@@ -5975,7 +5974,7 @@
           <a:p>
             <a:fld id="{5313799B-003D-4E1C-A5A0-25EACE4B1777}" type="datetime8">
               <a:rPr lang="en-KE" smtClean="0"/>
-              <a:t>03/24/2026 12:03</a:t>
+              <a:t>03/25/2026 08:59</a:t>
             </a:fld>
             <a:endParaRPr lang="en-KE"/>
           </a:p>
@@ -8659,7 +8658,7 @@
                 <a:latin typeface="Times New Roman" panose="02020603050405020304" pitchFamily="18" charset="0"/>
                 <a:ea typeface="Noto Serif CJK SC"/>
               </a:rPr>
-              <a:t>Consider the image shown in figure below and the case of a binary response variable (Y) with 1 is the presence of an observed parameter and 0 the absence of the observed parameter. The input layer contains predictor variables (X</a:t>
+              <a:t>Consider the image shown in figure 1 and the case of a binary response variable (Y) with 1 is the presence of an observed parameter and 0 the absence of the observed parameter. The input layer contains predictor variables (X</a:t>
             </a:r>
             <a:r>
               <a:rPr lang="en-US" sz="1800" kern="100" baseline="-25000" dirty="0">
@@ -8875,7 +8874,7 @@
           <a:p>
             <a:r>
               <a:rPr lang="en-US" dirty="0"/>
-              <a:t>Figure 3.1</a:t>
+              <a:t>Figure 1</a:t>
             </a:r>
             <a:endParaRPr lang="en-KE" dirty="0"/>
           </a:p>
@@ -9380,7 +9379,7 @@
         <p:spPr>
           <a:xfrm>
             <a:off x="914400" y="5943600"/>
-            <a:ext cx="1244251" cy="369332"/>
+            <a:ext cx="1051891" cy="369332"/>
           </a:xfrm>
           <a:prstGeom prst="rect">
             <a:avLst/>
@@ -9395,7 +9394,7 @@
           <a:p>
             <a:r>
               <a:rPr lang="en-US" dirty="0"/>
-              <a:t>Figure 3.2</a:t>
+              <a:t>Figure 2</a:t>
             </a:r>
             <a:endParaRPr lang="en-KE" dirty="0"/>
           </a:p>
@@ -9484,8 +9483,8 @@
         </p:nvSpPr>
         <p:spPr>
           <a:xfrm>
-            <a:off x="812801" y="2010878"/>
-            <a:ext cx="5279682" cy="4042233"/>
+            <a:off x="812801" y="1268361"/>
+            <a:ext cx="5279682" cy="5456903"/>
           </a:xfrm>
         </p:spPr>
         <p:txBody>
@@ -9585,6 +9584,12 @@
             <a:r>
               <a:rPr lang="en-US" dirty="0"/>
               <a:t>Facial Recognition datasets</a:t>
+            </a:r>
+          </a:p>
+          <a:p>
+            <a:r>
+              <a:rPr lang="en-US" dirty="0"/>
+              <a:t>Facial recognition architectures</a:t>
             </a:r>
           </a:p>
           <a:p>
@@ -9633,8 +9638,8 @@
         </p:nvSpPr>
         <p:spPr>
           <a:xfrm>
-            <a:off x="6413770" y="2017342"/>
-            <a:ext cx="4965429" cy="4042233"/>
+            <a:off x="6413770" y="1063416"/>
+            <a:ext cx="4965429" cy="5341866"/>
           </a:xfrm>
         </p:spPr>
         <p:txBody>
@@ -9642,12 +9647,6 @@
             <a:normAutofit/>
           </a:bodyPr>
           <a:lstStyle/>
-          <a:p>
-            <a:r>
-              <a:rPr lang="en-US" dirty="0"/>
-              <a:t>Facial recognition architectures</a:t>
-            </a:r>
-          </a:p>
           <a:p>
             <a:pPr>
               <a:buFont typeface="Wingdings" panose="05000000000000000000" pitchFamily="2" charset="2"/>
@@ -9681,6 +9680,68 @@
               <a:rPr lang="en-US" dirty="0"/>
               <a:t>Data Collection</a:t>
             </a:r>
+          </a:p>
+          <a:p>
+            <a:pPr>
+              <a:buFont typeface="Wingdings" panose="05000000000000000000" pitchFamily="2" charset="2"/>
+              <a:buChar char="q"/>
+            </a:pPr>
+            <a:r>
+              <a:rPr lang="en-US" dirty="0">
+                <a:solidFill>
+                  <a:schemeClr val="accent3">
+                    <a:lumMod val="75000"/>
+                  </a:schemeClr>
+                </a:solidFill>
+              </a:rPr>
+              <a:t>Results and Discussion</a:t>
+            </a:r>
+          </a:p>
+          <a:p>
+            <a:r>
+              <a:rPr lang="en-US" dirty="0"/>
+              <a:t>Cycks Model</a:t>
+            </a:r>
+          </a:p>
+          <a:p>
+            <a:r>
+              <a:rPr lang="en-US" dirty="0"/>
+              <a:t>VGG Model</a:t>
+            </a:r>
+          </a:p>
+          <a:p>
+            <a:r>
+              <a:rPr lang="en-US" dirty="0"/>
+              <a:t>Comparison Between Cycks and VGG</a:t>
+            </a:r>
+            <a:endParaRPr lang="en-US" dirty="0">
+              <a:solidFill>
+                <a:schemeClr val="accent3">
+                  <a:lumMod val="75000"/>
+                </a:schemeClr>
+              </a:solidFill>
+            </a:endParaRPr>
+          </a:p>
+          <a:p>
+            <a:pPr>
+              <a:buFont typeface="Wingdings" panose="05000000000000000000" pitchFamily="2" charset="2"/>
+              <a:buChar char="q"/>
+            </a:pPr>
+            <a:r>
+              <a:rPr lang="en-US" dirty="0">
+                <a:solidFill>
+                  <a:schemeClr val="accent3">
+                    <a:lumMod val="75000"/>
+                  </a:schemeClr>
+                </a:solidFill>
+              </a:rPr>
+              <a:t>Conclusion</a:t>
+            </a:r>
+          </a:p>
+          <a:p>
+            <a:pPr marL="0" indent="0">
+              <a:buNone/>
+            </a:pPr>
             <a:endParaRPr lang="en-KE" dirty="0"/>
           </a:p>
         </p:txBody>
@@ -9769,8 +9830,8 @@
           </a:p>
         </p:txBody>
       </p:sp>
-      <mc:AlternateContent xmlns:mc="http://schemas.openxmlformats.org/markup-compatibility/2006" xmlns:a14="http://schemas.microsoft.com/office/drawing/2010/main">
-        <mc:Choice Requires="a14">
+      <mc:AlternateContent xmlns:mc="http://schemas.openxmlformats.org/markup-compatibility/2006">
+        <mc:Choice xmlns:a14="http://schemas.microsoft.com/office/drawing/2010/main" Requires="a14">
           <p:sp>
             <p:nvSpPr>
               <p:cNvPr id="3" name="Content Placeholder 2">
@@ -10386,7 +10447,7 @@
                     <a:ea typeface="Noto Serif CJK SC"/>
                     <a:cs typeface="Lohit Devanagari"/>
                   </a:rPr>
-                  <a:t>(3.1)</a:t>
+                  <a:t>(1)</a:t>
                 </a:r>
                 <a:endParaRPr lang="en-KE" sz="1800" i="1" kern="100" dirty="0">
                   <a:effectLst/>
@@ -11056,7 +11117,7 @@
                     <a:ea typeface="Noto Serif CJK SC"/>
                     <a:cs typeface="Lohit Devanagari"/>
                   </a:rPr>
-                  <a:t>(3.2)</a:t>
+                  <a:t>(2)</a:t>
                 </a:r>
                 <a:endParaRPr lang="en-KE" sz="1800" i="1" kern="100" dirty="0">
                   <a:effectLst/>
@@ -11734,7 +11795,7 @@
                     <a:ea typeface="Noto Serif CJK SC"/>
                     <a:cs typeface="Lohit Devanagari"/>
                   </a:rPr>
-                  <a:t>3.4</a:t>
+                  <a:t>4</a:t>
                 </a:r>
                 <a:r>
                   <a:rPr lang="en-US" sz="1800" i="0" kern="100" dirty="0">
@@ -11980,7 +12041,7 @@
                     <a:ea typeface="Noto Serif CJK SC"/>
                     <a:cs typeface="Lohit Devanagari"/>
                   </a:rPr>
-                  <a:t>(3.5)</a:t>
+                  <a:t>(5)</a:t>
                 </a:r>
                 <a:endParaRPr lang="en-KE" sz="1800" i="1" kern="100" dirty="0">
                   <a:effectLst/>
@@ -12140,7 +12201,7 @@
                     <a:ea typeface="Noto Serif CJK SC"/>
                     <a:cs typeface="Lohit Devanagari"/>
                   </a:rPr>
-                  <a:t>                                               (3.6)</a:t>
+                  <a:t>                                               (6)</a:t>
                 </a:r>
                 <a:endParaRPr lang="en-KE" sz="1800" i="1" kern="100" dirty="0">
                   <a:effectLst/>
@@ -12304,7 +12365,7 @@
                     <a:ea typeface="Noto Serif CJK SC"/>
                     <a:cs typeface="Lohit Devanagari"/>
                   </a:rPr>
-                  <a:t>                                                (3.7)</a:t>
+                  <a:t>                                                (7)</a:t>
                 </a:r>
                 <a:endParaRPr lang="en-KE" sz="1800" i="1" kern="100" dirty="0">
                   <a:effectLst/>
@@ -12878,7 +12939,7 @@
                     <a:ea typeface="Noto Serif CJK SC"/>
                     <a:cs typeface="Lohit Devanagari"/>
                   </a:rPr>
-                  <a:t> (3.8)</a:t>
+                  <a:t> (8)</a:t>
                 </a:r>
                 <a:endParaRPr lang="en-KE" sz="1800" kern="100" dirty="0">
                   <a:effectLst/>
@@ -12910,7 +12971,7 @@
             </p:txBody>
           </p:sp>
         </mc:Choice>
-        <mc:Fallback xmlns="">
+        <mc:Fallback>
           <p:sp>
             <p:nvSpPr>
               <p:cNvPr id="3" name="Content Placeholder 2">
@@ -12944,7 +13005,7 @@
               <a:lstStyle/>
               <a:p>
                 <a:r>
-                  <a:rPr lang="en-KE">
+                  <a:rPr lang="en-US">
                     <a:noFill/>
                   </a:rPr>
                   <a:t> </a:t>
@@ -13043,8 +13104,8 @@
           </a:p>
         </p:txBody>
       </p:sp>
-      <mc:AlternateContent xmlns:mc="http://schemas.openxmlformats.org/markup-compatibility/2006" xmlns:a14="http://schemas.microsoft.com/office/drawing/2010/main">
-        <mc:Choice Requires="a14">
+      <mc:AlternateContent xmlns:mc="http://schemas.openxmlformats.org/markup-compatibility/2006">
+        <mc:Choice xmlns:a14="http://schemas.microsoft.com/office/drawing/2010/main" Requires="a14">
           <p:sp>
             <p:nvSpPr>
               <p:cNvPr id="3" name="Content Placeholder 2">
@@ -13282,7 +13343,7 @@
                     <a:ea typeface="Noto Serif CJK SC"/>
                     <a:cs typeface="Lohit Devanagari"/>
                   </a:rPr>
-                  <a:t>          (Obtained from the partial derivative of equation 3.4 with respect to </a:t>
+                  <a:t>          (Obtained from the partial derivative of equation 4 with respect to </a:t>
                 </a:r>
                 <a14:m>
                   <m:oMath xmlns:m="http://schemas.openxmlformats.org/officeDocument/2006/math">
@@ -13329,7 +13390,7 @@
                     <a:ea typeface="Noto Serif CJK SC"/>
                     <a:cs typeface="Lohit Devanagari"/>
                   </a:rPr>
-                  <a:t>)                                 </a:t>
+                  <a:t>)                                     </a:t>
                 </a:r>
                 <a:r>
                   <a:rPr lang="en-US" sz="1800" i="0" kern="100" dirty="0">
@@ -13338,7 +13399,7 @@
                     <a:ea typeface="Noto Serif CJK SC"/>
                     <a:cs typeface="Lohit Devanagari"/>
                   </a:rPr>
-                  <a:t>(3.9)</a:t>
+                  <a:t>(9)</a:t>
                 </a:r>
                 <a:endParaRPr lang="en-KE" sz="1800" i="1" kern="100" dirty="0">
                   <a:effectLst/>
@@ -13607,7 +13668,7 @@
                     <a:ea typeface="Noto Serif CJK SC"/>
                     <a:cs typeface="Lohit Devanagari"/>
                   </a:rPr>
-                  <a:t>                  (Obtained from equation 3.7)					</a:t>
+                  <a:t>                  (Obtained from equation 7)					</a:t>
                 </a:r>
                 <a:r>
                   <a:rPr lang="en-US" sz="1800" i="0" kern="100" dirty="0">
@@ -13616,7 +13677,7 @@
                     <a:ea typeface="Noto Serif CJK SC"/>
                     <a:cs typeface="Lohit Devanagari"/>
                   </a:rPr>
-                  <a:t>                                                  (3.10)</a:t>
+                  <a:t>                                                           (10)</a:t>
                 </a:r>
                 <a:endParaRPr lang="en-KE" sz="1800" i="1" kern="100" dirty="0">
                   <a:effectLst/>
@@ -13858,7 +13919,7 @@
                     <a:ea typeface="Noto Serif CJK SC"/>
                     <a:cs typeface="Lohit Devanagari"/>
                   </a:rPr>
-                  <a:t>        (Obtained from equation 3.8)					</a:t>
+                  <a:t>        (Obtained from equation 8)					</a:t>
                 </a:r>
                 <a:r>
                   <a:rPr lang="en-US" sz="1800" i="0" kern="100" dirty="0">
@@ -13867,7 +13928,7 @@
                     <a:ea typeface="Noto Serif CJK SC"/>
                     <a:cs typeface="Lohit Devanagari"/>
                   </a:rPr>
-                  <a:t>                                                   (</a:t>
+                  <a:t>                                                           (</a:t>
                 </a:r>
                 <a:r>
                   <a:rPr lang="en-US" sz="1800" kern="100" dirty="0">
@@ -13875,7 +13936,7 @@
                     <a:ea typeface="Noto Serif CJK SC"/>
                     <a:cs typeface="Lohit Devanagari"/>
                   </a:rPr>
-                  <a:t>3.11</a:t>
+                  <a:t>11</a:t>
                 </a:r>
                 <a:r>
                   <a:rPr lang="en-US" sz="1800" i="0" kern="100" dirty="0">
@@ -14269,7 +14330,7 @@
                     <a:ea typeface="Noto Serif CJK SC"/>
                     <a:cs typeface="Lohit Devanagari"/>
                   </a:rPr>
-                  <a:t>                                                           (3.12)</a:t>
+                  <a:t>                                                           (12)</a:t>
                 </a:r>
                 <a:endParaRPr lang="en-KE" sz="1800" i="1" kern="100" dirty="0">
                   <a:effectLst/>
@@ -14574,7 +14635,7 @@
                     <a:ea typeface="Noto Serif CJK SC"/>
                     <a:cs typeface="Lohit Devanagari"/>
                   </a:rPr>
-                  <a:t> be the learning rate. 										    (3.13)</a:t>
+                  <a:t> be the learning rate. 										    (13)</a:t>
                 </a:r>
               </a:p>
               <a:p>
@@ -14655,7 +14716,7 @@
             </p:txBody>
           </p:sp>
         </mc:Choice>
-        <mc:Fallback xmlns="">
+        <mc:Fallback>
           <p:sp>
             <p:nvSpPr>
               <p:cNvPr id="3" name="Content Placeholder 2">
@@ -14689,7 +14750,7 @@
               <a:lstStyle/>
               <a:p>
                 <a:r>
-                  <a:rPr lang="en-KE">
+                  <a:rPr lang="en-US">
                     <a:noFill/>
                   </a:rPr>
                   <a:t> </a:t>
@@ -14783,8 +14844,8 @@
           </a:p>
         </p:txBody>
       </p:sp>
-      <mc:AlternateContent xmlns:mc="http://schemas.openxmlformats.org/markup-compatibility/2006" xmlns:a14="http://schemas.microsoft.com/office/drawing/2010/main">
-        <mc:Choice Requires="a14">
+      <mc:AlternateContent xmlns:mc="http://schemas.openxmlformats.org/markup-compatibility/2006">
+        <mc:Choice xmlns:a14="http://schemas.microsoft.com/office/drawing/2010/main" Requires="a14">
           <p:sp>
             <p:nvSpPr>
               <p:cNvPr id="3" name="Content Placeholder 2">
@@ -15220,7 +15281,7 @@
                     <a:ea typeface="Noto Serif CJK SC"/>
                     <a:cs typeface="Lohit Devanagari"/>
                   </a:rPr>
-                  <a:t>                                                                                                (3.14)</a:t>
+                  <a:t>                                                                                                (14)</a:t>
                 </a:r>
                 <a:endParaRPr lang="en-US" sz="2900" kern="100" dirty="0">
                   <a:latin typeface="Liberation Serif"/>
@@ -15236,7 +15297,24 @@
                     <a:ea typeface="Noto Serif CJK SC"/>
                     <a:cs typeface="Lohit Devanagari"/>
                   </a:rPr>
-                  <a:t>Equation 3.13 can also be written as    </a:t>
+                  <a:t>Equation </a:t>
+                </a:r>
+                <a:r>
+                  <a:rPr lang="en-US" sz="2900" kern="100" dirty="0">
+                    <a:latin typeface="Liberation Serif"/>
+                    <a:ea typeface="Noto Serif CJK SC"/>
+                    <a:cs typeface="Lohit Devanagari"/>
+                  </a:rPr>
+                  <a:t>14</a:t>
+                </a:r>
+                <a:r>
+                  <a:rPr lang="en-US" sz="2900" kern="100" dirty="0">
+                    <a:effectLst/>
+                    <a:latin typeface="Liberation Serif"/>
+                    <a:ea typeface="Noto Serif CJK SC"/>
+                    <a:cs typeface="Lohit Devanagari"/>
+                  </a:rPr>
+                  <a:t> can also be written as    </a:t>
                 </a:r>
                 <a:r>
                   <a:rPr lang="en-KE" sz="2900" kern="100" dirty="0">
@@ -15488,7 +15566,24 @@
                     <a:ea typeface="Noto Serif CJK SC"/>
                     <a:cs typeface="Lohit Devanagari"/>
                   </a:rPr>
-                  <a:t>In short, we have shown through equation 3.13 that the neuron adjusts weights of the output layer by considering the difference the observed values and the actual values.</a:t>
+                  <a:t>In short, we have shown through equation </a:t>
+                </a:r>
+                <a:r>
+                  <a:rPr lang="en-US" sz="2900" kern="100" dirty="0">
+                    <a:latin typeface="Liberation Serif"/>
+                    <a:ea typeface="Noto Serif CJK SC"/>
+                    <a:cs typeface="Lohit Devanagari"/>
+                  </a:rPr>
+                  <a:t>14</a:t>
+                </a:r>
+                <a:r>
+                  <a:rPr lang="en-US" sz="2900" kern="100" dirty="0">
+                    <a:effectLst/>
+                    <a:latin typeface="Liberation Serif"/>
+                    <a:ea typeface="Noto Serif CJK SC"/>
+                    <a:cs typeface="Lohit Devanagari"/>
+                  </a:rPr>
+                  <a:t> that the neuron adjusts weights of the output layer by considering the difference the observed values and the actual values.</a:t>
                 </a:r>
               </a:p>
               <a:p>
@@ -15513,7 +15608,7 @@
             </p:txBody>
           </p:sp>
         </mc:Choice>
-        <mc:Fallback xmlns="">
+        <mc:Fallback>
           <p:sp>
             <p:nvSpPr>
               <p:cNvPr id="3" name="Content Placeholder 2">
@@ -15547,7 +15642,7 @@
               <a:lstStyle/>
               <a:p>
                 <a:r>
-                  <a:rPr lang="en-KE">
+                  <a:rPr lang="en-US">
                     <a:noFill/>
                   </a:rPr>
                   <a:t> </a:t>
@@ -15703,8 +15798,8 @@
         </p:nvSpPr>
         <p:spPr>
           <a:xfrm>
-            <a:off x="5654493" y="2056092"/>
-            <a:ext cx="5796672" cy="4200245"/>
+            <a:off x="5733151" y="2626982"/>
+            <a:ext cx="5796672" cy="2565069"/>
           </a:xfrm>
         </p:spPr>
         <p:txBody>
@@ -15717,7 +15812,7 @@
                 <a:latin typeface="Times New Roman" panose="02020603050405020304" pitchFamily="18" charset="0"/>
                 <a:ea typeface="Noto Serif CJK SC"/>
               </a:rPr>
-              <a:t>Convolution neural networks rely on their architecture to make predictions from inputs. This architecture can be divided into feature extraction and model prediction. The feature extraction phase relies on techniques such as filtering, the stride, padding, pooling and flattening. In order to explain how each of these techniques contributes to the architecture of the neural network we shall rely on the image shown in figure alongside</a:t>
+              <a:t>Convolution neural networks rely on their architecture to make predictions from inputs. This architecture can be divided into feature extraction and model prediction. The feature extraction phase relies on techniques such as filtering, the stride, padding, pooling and flattening. In order to explain how each of these techniques contributes to the architecture of the neural network we shall rely on the image shown in figure 3 alongside</a:t>
             </a:r>
             <a:endParaRPr lang="en-KE" dirty="0"/>
           </a:p>
@@ -15766,8 +15861,8 @@
         </p:nvSpPr>
         <p:spPr>
           <a:xfrm>
-            <a:off x="939800" y="5626100"/>
-            <a:ext cx="1244251" cy="369332"/>
+            <a:off x="1817515" y="5192051"/>
+            <a:ext cx="1051891" cy="369332"/>
           </a:xfrm>
           <a:prstGeom prst="rect">
             <a:avLst/>
@@ -15782,7 +15877,7 @@
           <a:p>
             <a:r>
               <a:rPr lang="en-US" dirty="0"/>
-              <a:t>Figure 3.3</a:t>
+              <a:t>Figure 3</a:t>
             </a:r>
             <a:endParaRPr lang="en-KE" dirty="0"/>
           </a:p>
@@ -15914,7 +16009,7 @@
                 <a:latin typeface="Times New Roman" panose="02020603050405020304" pitchFamily="18" charset="0"/>
                 <a:ea typeface="Noto Serif CJK SC"/>
               </a:rPr>
-              <a:t>The kernel in figure 3.3 above slides from R1 to row R3 and from column C1 to column C3 and multiplies the resulting matrix with the kernel. In this case, the result of the dot multiplication is 12. It then slides over and beginning form row R2 to row R4 and column C1 to column C3. The result of this dot multiplication is also 12. The last filter happens from row R3 to row R5 and column C1 to column C3. The result from this dot multiplication is 17.</a:t>
+              <a:t>The kernel in figure 3 above slides from R1 to row R3 and from column C1 to column C3 and multiplies the resulting matrix with the kernel. In this case, the result of the dot multiplication is 12. It then slides over and beginning form row R2 to row R4 and column C1 to column C3. The result of this dot multiplication is also 12. The last filter happens from row R3 to row R5 and column C1 to column C3. The result from this dot multiplication is 17.</a:t>
             </a:r>
           </a:p>
           <a:p>
@@ -15934,7 +16029,7 @@
                 <a:latin typeface="Times New Roman" panose="02020603050405020304" pitchFamily="18" charset="0"/>
                 <a:ea typeface="Noto Serif CJK SC"/>
               </a:rPr>
-              <a:t> It then slides from row R3 to R5 and multiplies the resulting matrix with itself to give 19. The procedure is through rows R1 to R5 and columns C3 to C5 to give 9, 6 and 14 as the results. The results are combined into what is called the feature map and is shown in the figure alongside</a:t>
+              <a:t> It then slides from row R3 to R5 and multiplies the resulting matrix with itself to give 19. The procedure is through rows R1 to R5 and columns C3 to C5 to give 9, 6 and 14 as the results. The results are combined into what is called the feature map and is shown in the figure 4 alongside</a:t>
             </a:r>
           </a:p>
           <a:p>
@@ -15986,7 +16081,7 @@
         <p:spPr>
           <a:xfrm>
             <a:off x="457200" y="5448300"/>
-            <a:ext cx="1244251" cy="369332"/>
+            <a:ext cx="1051891" cy="369332"/>
           </a:xfrm>
           <a:prstGeom prst="rect">
             <a:avLst/>
@@ -16001,7 +16096,7 @@
           <a:p>
             <a:r>
               <a:rPr lang="en-US" dirty="0"/>
-              <a:t>Figure 3.4</a:t>
+              <a:t>Figure 4</a:t>
             </a:r>
             <a:endParaRPr lang="en-KE" dirty="0"/>
           </a:p>
@@ -16150,7 +16245,7 @@
                 <a:ea typeface="Noto Serif CJK SC"/>
                 <a:cs typeface="Lohit Devanagari"/>
               </a:rPr>
-              <a:t>Let us take the sample matrix and kernel in figure 3.3 above into consideration (assuming that we have a stride of 1) and use it to explain how strides are used in convolution neural networks.</a:t>
+              <a:t>Let us take the sample matrix and kernel in figure 3 above into consideration (assuming that we have a stride of 1) and use it to explain how strides are used in convolution neural networks.</a:t>
             </a:r>
           </a:p>
           <a:p>
@@ -16203,7 +16298,7 @@
                 <a:ea typeface="Noto Serif CJK SC"/>
                 <a:cs typeface="Lohit Devanagari"/>
               </a:rPr>
-              <a:t> In short, the matrix and kernel in figure 3.4 and a stride of 1 will produce a feature map shown in figure 3.5 alongside.</a:t>
+              <a:t> In short, the matrix and kernel in figure 4 and a stride of 1 will produce a feature map shown in figure 5 alongside.</a:t>
             </a:r>
             <a:endParaRPr lang="en-KE" sz="1800" kern="100" dirty="0">
               <a:effectLst/>
@@ -16261,7 +16356,7 @@
         <p:spPr>
           <a:xfrm>
             <a:off x="635000" y="5295900"/>
-            <a:ext cx="1244251" cy="369332"/>
+            <a:ext cx="1051891" cy="369332"/>
           </a:xfrm>
           <a:prstGeom prst="rect">
             <a:avLst/>
@@ -16276,7 +16371,7 @@
           <a:p>
             <a:r>
               <a:rPr lang="en-US" dirty="0"/>
-              <a:t>Figure 3.5</a:t>
+              <a:t>Figure 5</a:t>
             </a:r>
             <a:endParaRPr lang="en-KE" dirty="0"/>
           </a:p>
@@ -16456,7 +16551,7 @@
                 <a:latin typeface="Times New Roman" panose="02020603050405020304" pitchFamily="18" charset="0"/>
                 <a:ea typeface="Noto Serif CJK SC"/>
               </a:rPr>
-              <a:t>sample matrix in the figure 3.3 above</a:t>
+              <a:t>sample matrix in the figure 3 above</a:t>
             </a:r>
             <a:r>
               <a:rPr lang="en-KE" sz="2000" kern="100" dirty="0">
@@ -16464,7 +16559,7 @@
                 <a:latin typeface="Times New Roman" panose="02020603050405020304" pitchFamily="18" charset="0"/>
                 <a:ea typeface="Noto Serif CJK SC"/>
               </a:rPr>
-              <a:t>, adding zeros around the matrix produces the matrix (a) in figure 3.</a:t>
+              <a:t>, adding zeros around the matrix produces the matrix (a) in figure </a:t>
             </a:r>
             <a:r>
               <a:rPr lang="en-US" sz="2000" kern="100" dirty="0">
@@ -16495,7 +16590,7 @@
                 <a:latin typeface="Times New Roman" panose="02020603050405020304" pitchFamily="18" charset="0"/>
                 <a:ea typeface="Noto Serif CJK SC"/>
               </a:rPr>
-              <a:t>The matrix (a) in figure 3.</a:t>
+              <a:t>The matrix (a) in figure </a:t>
             </a:r>
             <a:r>
               <a:rPr lang="en-US" sz="2000" kern="100" dirty="0">
@@ -16527,7 +16622,7 @@
                 <a:latin typeface="Times New Roman" panose="02020603050405020304" pitchFamily="18" charset="0"/>
                 <a:ea typeface="Noto Serif CJK SC"/>
               </a:rPr>
-              <a:t> is then subjected to a filter using the kernel in figure 3.4 to produce the matrix(b) in figure 3.</a:t>
+              <a:t> is then subjected to a filter using the kernel in figure 4 to produce the matrix(b) in figure 3.</a:t>
             </a:r>
             <a:r>
               <a:rPr lang="en-US" sz="2000" kern="100" dirty="0">
@@ -16574,7 +16669,7 @@
                 <a:latin typeface="Times New Roman" panose="02020603050405020304" pitchFamily="18" charset="0"/>
                 <a:ea typeface="Noto Serif CJK SC"/>
               </a:rPr>
-              <a:t>It is important to note that the dimension of the matrix(b) in figure 3.</a:t>
+              <a:t>It is important to note that the dimension of the matrix(b) in figure </a:t>
             </a:r>
             <a:r>
               <a:rPr lang="en-US" sz="2000" kern="100" dirty="0">
@@ -16590,23 +16685,7 @@
                 <a:latin typeface="Times New Roman" panose="02020603050405020304" pitchFamily="18" charset="0"/>
                 <a:ea typeface="Noto Serif CJK SC"/>
               </a:rPr>
-              <a:t> below is equal to the dimension of the sample matrix in figure 3.</a:t>
-            </a:r>
-            <a:r>
-              <a:rPr lang="en-US" sz="2000" kern="100" dirty="0">
-                <a:effectLst/>
-                <a:latin typeface="Times New Roman" panose="02020603050405020304" pitchFamily="18" charset="0"/>
-                <a:ea typeface="Noto Serif CJK SC"/>
-              </a:rPr>
-              <a:t>3</a:t>
-            </a:r>
-            <a:r>
-              <a:rPr lang="en-KE" sz="2000" kern="100" dirty="0">
-                <a:effectLst/>
-                <a:latin typeface="Times New Roman" panose="02020603050405020304" pitchFamily="18" charset="0"/>
-                <a:ea typeface="Noto Serif CJK SC"/>
-              </a:rPr>
-              <a:t> above.</a:t>
+              <a:t> below is equal to the dimension of the sample matrix in figure 3 above.</a:t>
             </a:r>
             <a:endParaRPr lang="en-KE" sz="2000" dirty="0"/>
           </a:p>
@@ -16656,7 +16735,7 @@
         <p:spPr>
           <a:xfrm>
             <a:off x="444500" y="5829300"/>
-            <a:ext cx="1244251" cy="369332"/>
+            <a:ext cx="1051891" cy="369332"/>
           </a:xfrm>
           <a:prstGeom prst="rect">
             <a:avLst/>
@@ -16671,7 +16750,7 @@
           <a:p>
             <a:r>
               <a:rPr lang="en-US" dirty="0"/>
-              <a:t>Figure 3.6</a:t>
+              <a:t>Figure 6</a:t>
             </a:r>
             <a:endParaRPr lang="en-KE" dirty="0"/>
           </a:p>
@@ -16857,7 +16936,7 @@
                 <a:ea typeface="Noto Serif CJK SC"/>
                 <a:cs typeface="Times New Roman" panose="02020603050405020304" pitchFamily="18" charset="0"/>
               </a:rPr>
-              <a:t>In contrast, rather than take the maximum value from each matrix it finds the averages and concatenates the results as shown in the matrix called average pooling in figure 3.7 alongside.</a:t>
+              <a:t>In contrast, rather than take the maximum value from each matrix it finds the averages and concatenates the results as shown in the matrix called average pooling in figure 7 alongside.</a:t>
             </a:r>
             <a:endParaRPr lang="en-KE" sz="2600" kern="100" dirty="0">
               <a:effectLst/>
@@ -16915,7 +16994,7 @@
         <p:spPr>
           <a:xfrm>
             <a:off x="203200" y="5214857"/>
-            <a:ext cx="1244251" cy="369332"/>
+            <a:ext cx="1051891" cy="369332"/>
           </a:xfrm>
           <a:prstGeom prst="rect">
             <a:avLst/>
@@ -16930,7 +17009,7 @@
           <a:p>
             <a:r>
               <a:rPr lang="en-US" dirty="0"/>
-              <a:t>Figure 3.7</a:t>
+              <a:t>Figure 7</a:t>
             </a:r>
             <a:endParaRPr lang="en-KE" dirty="0"/>
           </a:p>
@@ -17000,8 +17079,8 @@
           </a:p>
         </p:txBody>
       </p:sp>
-      <mc:AlternateContent xmlns:mc="http://schemas.openxmlformats.org/markup-compatibility/2006" xmlns:a14="http://schemas.microsoft.com/office/drawing/2010/main">
-        <mc:Choice Requires="a14">
+      <mc:AlternateContent xmlns:mc="http://schemas.openxmlformats.org/markup-compatibility/2006">
+        <mc:Choice xmlns:a14="http://schemas.microsoft.com/office/drawing/2010/main" Requires="a14">
           <p:sp>
             <p:nvSpPr>
               <p:cNvPr id="3" name="Content Placeholder 2">
@@ -17075,7 +17154,7 @@
                     <a:ea typeface="Noto Serif CJK SC"/>
                     <a:cs typeface="Lohit Devanagari"/>
                   </a:rPr>
-                  <a:t>That said, this technique occurs by adjusting the values in each variable using the mean, standard deviation, scaling parameter, and a bias. This is done using equation 3.15 below. It is important to highlight that the scaling parameter and the bias, like the weights of a neural network, are adjusted in order to minimize the loss function.</a:t>
+                  <a:t>That said, this technique occurs by adjusting the values in each variable using the mean, standard deviation, scaling parameter, and a bias. This is done using equation 15 below. It is important to highlight that the scaling parameter and the bias, like the weights of a neural network, are adjusted in order to minimize the loss function.</a:t>
                 </a:r>
                 <a:endParaRPr lang="en-KE" kern="100" dirty="0">
                   <a:effectLst/>
@@ -17241,7 +17320,7 @@
                     <a:ea typeface="Noto Serif CJK SC"/>
                     <a:cs typeface="Lohit Devanagari"/>
                   </a:rPr>
-                  <a:t>                                                                                                           3.15</a:t>
+                  <a:t>                                                                                                           15</a:t>
                 </a:r>
                 <a:endParaRPr lang="en-KE" i="1" kern="100" dirty="0">
                   <a:effectLst/>
@@ -17518,7 +17597,7 @@
                     <a:ea typeface="Noto Serif CJK SC"/>
                     <a:cs typeface="Lohit Devanagari"/>
                   </a:rPr>
-                  <a:t>                                                                                                                                3.16</a:t>
+                  <a:t>                                                                                                                                16</a:t>
                 </a:r>
                 <a:endParaRPr lang="en-KE" i="1" kern="100" dirty="0">
                   <a:effectLst/>
@@ -17533,7 +17612,7 @@
             </p:txBody>
           </p:sp>
         </mc:Choice>
-        <mc:Fallback xmlns="">
+        <mc:Fallback>
           <p:sp>
             <p:nvSpPr>
               <p:cNvPr id="3" name="Content Placeholder 2">
@@ -17567,7 +17646,7 @@
               <a:lstStyle/>
               <a:p>
                 <a:r>
-                  <a:rPr lang="en-KE">
+                  <a:rPr lang="en-US">
                     <a:noFill/>
                   </a:rPr>
                   <a:t> </a:t>
@@ -17735,25 +17814,7 @@
                 <a:ea typeface="Noto Serif CJK SC"/>
                 <a:cs typeface="Times New Roman" panose="02020603050405020304" pitchFamily="18" charset="0"/>
               </a:rPr>
-              <a:t>The Komnet dataset was chosen for the study because </a:t>
-            </a:r>
-            <a:r>
-              <a:rPr lang="en-US" kern="100" dirty="0" err="1">
-                <a:effectLst/>
-                <a:latin typeface="Times New Roman" panose="02020603050405020304" pitchFamily="18" charset="0"/>
-                <a:ea typeface="Noto Serif CJK SC"/>
-                <a:cs typeface="Times New Roman" panose="02020603050405020304" pitchFamily="18" charset="0"/>
-              </a:rPr>
-              <a:t>Astawa</a:t>
-            </a:r>
-            <a:r>
-              <a:rPr lang="en-US" kern="100" dirty="0">
-                <a:effectLst/>
-                <a:latin typeface="Times New Roman" panose="02020603050405020304" pitchFamily="18" charset="0"/>
-                <a:ea typeface="Noto Serif CJK SC"/>
-                <a:cs typeface="Times New Roman" panose="02020603050405020304" pitchFamily="18" charset="0"/>
-              </a:rPr>
-              <a:t> et al., 2020, the authors of the data set give users permission to use and even improve the dataset. Moreso, the size of the data set is small enough, which allows the researcher to conduct the experiment at a minimal cost.</a:t>
+              <a:t>The Komnet dataset was chosen for the study because Astawa et al., 2020, the authors of the data set give users permission to use and even improve the dataset. Moreso, the size of the data set is small enough, which allows the researcher to conduct the experiment at a minimal cost.</a:t>
             </a:r>
             <a:endParaRPr lang="en-KE" kern="100" dirty="0">
               <a:effectLst/>
@@ -18077,12 +18138,22 @@
             </a:r>
             <a:r>
               <a:rPr lang="en-US" dirty="0"/>
-              <a:t> conducted the experiment several times just to ascertain the accuracy and quality of the results collected for the experiment.</a:t>
-            </a:r>
-          </a:p>
-          <a:p>
-            <a:r>
-              <a:rPr lang="en-US" dirty="0"/>
+              <a:t> </a:t>
+            </a:r>
+            <a:r>
+              <a:rPr lang="en-US" dirty="0">
+                <a:latin typeface="Times New Roman" panose="02020603050405020304" pitchFamily="18" charset="0"/>
+                <a:cs typeface="Times New Roman" panose="02020603050405020304" pitchFamily="18" charset="0"/>
+              </a:rPr>
+              <a:t>conducted the experiment several times just to ascertain the accuracy and quality of the results collected for the experiment.</a:t>
+            </a:r>
+          </a:p>
+          <a:p>
+            <a:r>
+              <a:rPr lang="en-US" dirty="0">
+                <a:latin typeface="Times New Roman" panose="02020603050405020304" pitchFamily="18" charset="0"/>
+                <a:cs typeface="Times New Roman" panose="02020603050405020304" pitchFamily="18" charset="0"/>
+              </a:rPr>
               <a:t>For example, the author was able to establish that some of the users in the dataset did not have enough images to produce quality results and were excluded from the experiment.</a:t>
             </a:r>
           </a:p>
@@ -18231,7 +18302,7 @@
           <a:p>
             <a:r>
               <a:rPr lang="en-US" dirty="0"/>
-              <a:t>Figure 4.1</a:t>
+              <a:t>Figure 8</a:t>
             </a:r>
           </a:p>
         </p:txBody>
@@ -18293,14 +18364,20 @@
           <a:lstStyle/>
           <a:p>
             <a:r>
-              <a:rPr lang="en-US" dirty="0"/>
-              <a:t>As you can see from figure 4.1 above user 15 and user 20 recorded very low scores in precision, recall, and F-Score. It is because the users had very few images compared to other users. Data from user 15 and user 20 were excluded from the analysis. </a:t>
-            </a:r>
-          </a:p>
-          <a:p>
-            <a:r>
-              <a:rPr lang="en-US" dirty="0"/>
-              <a:t>As you can see from figure 4.2 below the performance of the model called Cycks_without_padding improved after dropping images from the two users.</a:t>
+              <a:rPr lang="en-US" dirty="0">
+                <a:latin typeface="Times New Roman" panose="02020603050405020304" pitchFamily="18" charset="0"/>
+                <a:cs typeface="Times New Roman" panose="02020603050405020304" pitchFamily="18" charset="0"/>
+              </a:rPr>
+              <a:t>As you can see from figure 8 above user 15 and user 20 recorded very low scores in precision, recall, and F-Score. It is because the users had very few images compared to other users. Data from user 15 and user 20 were excluded from the analysis. </a:t>
+            </a:r>
+          </a:p>
+          <a:p>
+            <a:r>
+              <a:rPr lang="en-US" dirty="0">
+                <a:latin typeface="Times New Roman" panose="02020603050405020304" pitchFamily="18" charset="0"/>
+                <a:cs typeface="Times New Roman" panose="02020603050405020304" pitchFamily="18" charset="0"/>
+              </a:rPr>
+              <a:t>As you can see from figure 9 below the performance of the model called Cycks without padding improved after dropping images from the two users.</a:t>
             </a:r>
           </a:p>
         </p:txBody>
@@ -18385,7 +18462,7 @@
         <p:spPr>
           <a:xfrm>
             <a:off x="7187381" y="6062609"/>
-            <a:ext cx="1244251" cy="369332"/>
+            <a:ext cx="1051891" cy="369332"/>
           </a:xfrm>
           <a:prstGeom prst="rect">
             <a:avLst/>
@@ -18400,7 +18477,7 @@
           <a:p>
             <a:r>
               <a:rPr lang="en-US" dirty="0"/>
-              <a:t>Figure 4.2</a:t>
+              <a:t>Figure 9</a:t>
             </a:r>
           </a:p>
         </p:txBody>
@@ -18461,10 +18538,7 @@
           <a:bodyPr/>
           <a:lstStyle/>
           <a:p>
-            <a:r>
-              <a:rPr lang="en-US" dirty="0"/>
-              <a:t>c</a:t>
-            </a:r>
+            <a:endParaRPr lang="en-US" dirty="0"/>
           </a:p>
         </p:txBody>
       </p:sp>
@@ -18496,7 +18570,39 @@
           <a:p>
             <a:r>
               <a:rPr lang="en-US" dirty="0"/>
-              <a:t>The researcher was able to build two models called cycks_with_padding and cycks_without_padding. The cycks_with_padding model was built with padding while the cycks_without_padding was built without padding.</a:t>
+              <a:t>The researcher was able to build two models called </a:t>
+            </a:r>
+            <a:r>
+              <a:rPr lang="en-US" dirty="0" err="1"/>
+              <a:t>cycks</a:t>
+            </a:r>
+            <a:r>
+              <a:rPr lang="en-US" dirty="0"/>
+              <a:t> with padding and </a:t>
+            </a:r>
+            <a:r>
+              <a:rPr lang="en-US" dirty="0" err="1"/>
+              <a:t>cycks</a:t>
+            </a:r>
+            <a:r>
+              <a:rPr lang="en-US" dirty="0"/>
+              <a:t> without padding. The </a:t>
+            </a:r>
+            <a:r>
+              <a:rPr lang="en-US" dirty="0" err="1"/>
+              <a:t>cycks</a:t>
+            </a:r>
+            <a:r>
+              <a:rPr lang="en-US" dirty="0"/>
+              <a:t> with padding model was built with padding while the </a:t>
+            </a:r>
+            <a:r>
+              <a:rPr lang="en-US" dirty="0" err="1"/>
+              <a:t>cycks</a:t>
+            </a:r>
+            <a:r>
+              <a:rPr lang="en-US" dirty="0"/>
+              <a:t> without padding was built without padding.</a:t>
             </a:r>
           </a:p>
         </p:txBody>
@@ -18530,12 +18636,47 @@
           </a:p>
         </p:txBody>
       </p:sp>
+      <p:sp>
+        <p:nvSpPr>
+          <p:cNvPr id="7" name="TextBox 6">
+            <a:extLst>
+              <a:ext uri="{FF2B5EF4-FFF2-40B4-BE49-F238E27FC236}">
+                <a16:creationId xmlns:a16="http://schemas.microsoft.com/office/drawing/2014/main" id="{613E89A6-A3A8-30FA-E65F-D43A331F62D4}"/>
+              </a:ext>
+            </a:extLst>
+          </p:cNvPr>
+          <p:cNvSpPr txBox="1"/>
+          <p:nvPr/>
+        </p:nvSpPr>
+        <p:spPr>
+          <a:xfrm>
+            <a:off x="4208664" y="6313152"/>
+            <a:ext cx="1641987" cy="369332"/>
+          </a:xfrm>
+          <a:prstGeom prst="rect">
+            <a:avLst/>
+          </a:prstGeom>
+          <a:noFill/>
+        </p:spPr>
+        <p:txBody>
+          <a:bodyPr wrap="square" rtlCol="0">
+            <a:spAutoFit/>
+          </a:bodyPr>
+          <a:lstStyle/>
+          <a:p>
+            <a:r>
+              <a:rPr lang="en-US" dirty="0"/>
+              <a:t>Figure 10</a:t>
+            </a:r>
+          </a:p>
+        </p:txBody>
+      </p:sp>
       <p:pic>
         <p:nvPicPr>
-          <p:cNvPr id="6" name="Picture 5">
+          <p:cNvPr id="5" name="Picture 4">
             <a:extLst>
               <a:ext uri="{FF2B5EF4-FFF2-40B4-BE49-F238E27FC236}">
-                <a16:creationId xmlns:a16="http://schemas.microsoft.com/office/drawing/2014/main" id="{C0768A5F-97AD-69A5-495C-FE2354C963C2}"/>
+                <a16:creationId xmlns:a16="http://schemas.microsoft.com/office/drawing/2014/main" id="{412B3DD3-A6BC-0252-457F-361C478A221B}"/>
               </a:ext>
             </a:extLst>
           </p:cNvPr>
@@ -18558,79 +18699,8 @@
         </p:blipFill>
         <p:spPr>
           <a:xfrm>
-            <a:off x="150763" y="2319224"/>
-            <a:ext cx="5561779" cy="3901778"/>
-          </a:xfrm>
-          <a:prstGeom prst="rect">
-            <a:avLst/>
-          </a:prstGeom>
-        </p:spPr>
-      </p:pic>
-      <p:sp>
-        <p:nvSpPr>
-          <p:cNvPr id="7" name="TextBox 6">
-            <a:extLst>
-              <a:ext uri="{FF2B5EF4-FFF2-40B4-BE49-F238E27FC236}">
-                <a16:creationId xmlns:a16="http://schemas.microsoft.com/office/drawing/2014/main" id="{613E89A6-A3A8-30FA-E65F-D43A331F62D4}"/>
-              </a:ext>
-            </a:extLst>
-          </p:cNvPr>
-          <p:cNvSpPr txBox="1"/>
-          <p:nvPr/>
-        </p:nvSpPr>
-        <p:spPr>
-          <a:xfrm>
-            <a:off x="4975580" y="6259565"/>
-            <a:ext cx="1641987" cy="369332"/>
-          </a:xfrm>
-          <a:prstGeom prst="rect">
-            <a:avLst/>
-          </a:prstGeom>
-          <a:noFill/>
-        </p:spPr>
-        <p:txBody>
-          <a:bodyPr wrap="square" rtlCol="0">
-            <a:spAutoFit/>
-          </a:bodyPr>
-          <a:lstStyle/>
-          <a:p>
-            <a:r>
-              <a:rPr lang="en-US" dirty="0"/>
-              <a:t>Figure 4.3</a:t>
-            </a:r>
-          </a:p>
-        </p:txBody>
-      </p:sp>
-      <p:pic>
-        <p:nvPicPr>
-          <p:cNvPr id="9" name="Picture 8">
-            <a:extLst>
-              <a:ext uri="{FF2B5EF4-FFF2-40B4-BE49-F238E27FC236}">
-                <a16:creationId xmlns:a16="http://schemas.microsoft.com/office/drawing/2014/main" id="{0C89051F-A0F1-7F98-11A2-3FC088C96EF3}"/>
-              </a:ext>
-            </a:extLst>
-          </p:cNvPr>
-          <p:cNvPicPr>
-            <a:picLocks noChangeAspect="1"/>
-          </p:cNvPicPr>
-          <p:nvPr/>
-        </p:nvPicPr>
-        <p:blipFill>
-          <a:blip r:embed="rId3">
-            <a:extLst>
-              <a:ext uri="{28A0092B-C50C-407E-A947-70E740481C1C}">
-                <a14:useLocalDpi xmlns:a14="http://schemas.microsoft.com/office/drawing/2010/main" val="0"/>
-              </a:ext>
-            </a:extLst>
-          </a:blip>
-          <a:stretch>
-            <a:fillRect/>
-          </a:stretch>
-        </p:blipFill>
-        <p:spPr>
-          <a:xfrm>
-            <a:off x="5807586" y="2319224"/>
-            <a:ext cx="6040286" cy="3901778"/>
+            <a:off x="1748962" y="2205877"/>
+            <a:ext cx="6561389" cy="3901778"/>
           </a:xfrm>
           <a:prstGeom prst="rect">
             <a:avLst/>
@@ -18728,13 +18798,21 @@
           <a:p>
             <a:r>
               <a:rPr lang="en-US" dirty="0"/>
-              <a:t>Results from figure 4.3 indicate that padding does not improve model performance. Instead, the absence of it improves model performance. </a:t>
+              <a:t>Results from figure 10 indicate that padding does not improve model performance. Instead, the absence of it improves model performance. </a:t>
             </a:r>
           </a:p>
           <a:p>
             <a:r>
               <a:rPr lang="en-US" dirty="0"/>
-              <a:t>All performance metrics increased on the cycks model without padding.</a:t>
+              <a:t>All performance metrics increased on the </a:t>
+            </a:r>
+            <a:r>
+              <a:rPr lang="en-US" dirty="0" err="1"/>
+              <a:t>cycks</a:t>
+            </a:r>
+            <a:r>
+              <a:rPr lang="en-US" dirty="0"/>
+              <a:t> model without padding.</a:t>
             </a:r>
           </a:p>
           <a:p>
@@ -18905,12 +18983,47 @@
           </a:p>
         </p:txBody>
       </p:sp>
+      <p:sp>
+        <p:nvSpPr>
+          <p:cNvPr id="9" name="TextBox 8">
+            <a:extLst>
+              <a:ext uri="{FF2B5EF4-FFF2-40B4-BE49-F238E27FC236}">
+                <a16:creationId xmlns:a16="http://schemas.microsoft.com/office/drawing/2014/main" id="{66845D25-AE04-5154-0C28-45842EF2679F}"/>
+              </a:ext>
+            </a:extLst>
+          </p:cNvPr>
+          <p:cNvSpPr txBox="1"/>
+          <p:nvPr/>
+        </p:nvSpPr>
+        <p:spPr>
+          <a:xfrm>
+            <a:off x="4119716" y="6142869"/>
+            <a:ext cx="1976284" cy="369332"/>
+          </a:xfrm>
+          <a:prstGeom prst="rect">
+            <a:avLst/>
+          </a:prstGeom>
+          <a:noFill/>
+        </p:spPr>
+        <p:txBody>
+          <a:bodyPr wrap="square" rtlCol="0">
+            <a:spAutoFit/>
+          </a:bodyPr>
+          <a:lstStyle/>
+          <a:p>
+            <a:r>
+              <a:rPr lang="en-US" dirty="0"/>
+              <a:t>Figure 11</a:t>
+            </a:r>
+          </a:p>
+        </p:txBody>
+      </p:sp>
       <p:pic>
         <p:nvPicPr>
-          <p:cNvPr id="6" name="Picture 5">
+          <p:cNvPr id="11" name="Picture 10">
             <a:extLst>
               <a:ext uri="{FF2B5EF4-FFF2-40B4-BE49-F238E27FC236}">
-                <a16:creationId xmlns:a16="http://schemas.microsoft.com/office/drawing/2014/main" id="{68CFB60B-2369-706A-B776-65CB59462354}"/>
+                <a16:creationId xmlns:a16="http://schemas.microsoft.com/office/drawing/2014/main" id="{97C0B7CC-E39F-C39E-00D2-15D4BB306443}"/>
               </a:ext>
             </a:extLst>
           </p:cNvPr>
@@ -18933,85 +19046,14 @@
         </p:blipFill>
         <p:spPr>
           <a:xfrm>
-            <a:off x="91769" y="2333518"/>
-            <a:ext cx="5699431" cy="3978792"/>
+            <a:off x="2667821" y="2177947"/>
+            <a:ext cx="6561389" cy="3901778"/>
           </a:xfrm>
           <a:prstGeom prst="rect">
             <a:avLst/>
           </a:prstGeom>
         </p:spPr>
       </p:pic>
-      <p:pic>
-        <p:nvPicPr>
-          <p:cNvPr id="8" name="Picture 7">
-            <a:extLst>
-              <a:ext uri="{FF2B5EF4-FFF2-40B4-BE49-F238E27FC236}">
-                <a16:creationId xmlns:a16="http://schemas.microsoft.com/office/drawing/2014/main" id="{4517BBED-0174-3693-2D16-6735643B4F46}"/>
-              </a:ext>
-            </a:extLst>
-          </p:cNvPr>
-          <p:cNvPicPr>
-            <a:picLocks noChangeAspect="1"/>
-          </p:cNvPicPr>
-          <p:nvPr/>
-        </p:nvPicPr>
-        <p:blipFill>
-          <a:blip r:embed="rId3">
-            <a:extLst>
-              <a:ext uri="{28A0092B-C50C-407E-A947-70E740481C1C}">
-                <a14:useLocalDpi xmlns:a14="http://schemas.microsoft.com/office/drawing/2010/main" val="0"/>
-              </a:ext>
-            </a:extLst>
-          </a:blip>
-          <a:stretch>
-            <a:fillRect/>
-          </a:stretch>
-        </p:blipFill>
-        <p:spPr>
-          <a:xfrm>
-            <a:off x="5882968" y="2333518"/>
-            <a:ext cx="6217263" cy="3978792"/>
-          </a:xfrm>
-          <a:prstGeom prst="rect">
-            <a:avLst/>
-          </a:prstGeom>
-        </p:spPr>
-      </p:pic>
-      <p:sp>
-        <p:nvSpPr>
-          <p:cNvPr id="9" name="TextBox 8">
-            <a:extLst>
-              <a:ext uri="{FF2B5EF4-FFF2-40B4-BE49-F238E27FC236}">
-                <a16:creationId xmlns:a16="http://schemas.microsoft.com/office/drawing/2014/main" id="{66845D25-AE04-5154-0C28-45842EF2679F}"/>
-              </a:ext>
-            </a:extLst>
-          </p:cNvPr>
-          <p:cNvSpPr txBox="1"/>
-          <p:nvPr/>
-        </p:nvSpPr>
-        <p:spPr>
-          <a:xfrm>
-            <a:off x="4119717" y="6438598"/>
-            <a:ext cx="1976284" cy="369332"/>
-          </a:xfrm>
-          <a:prstGeom prst="rect">
-            <a:avLst/>
-          </a:prstGeom>
-          <a:noFill/>
-        </p:spPr>
-        <p:txBody>
-          <a:bodyPr wrap="square" rtlCol="0">
-            <a:spAutoFit/>
-          </a:bodyPr>
-          <a:lstStyle/>
-          <a:p>
-            <a:r>
-              <a:rPr lang="en-US" dirty="0"/>
-              <a:t>Figure 4.4</a:t>
-            </a:r>
-          </a:p>
-        </p:txBody>
-      </p:sp>
     </p:spTree>
     <p:extLst>
       <p:ext uri="{BB962C8B-B14F-4D97-AF65-F5344CB8AC3E}">
@@ -19288,7 +19330,15 @@
           <a:p>
             <a:r>
               <a:rPr lang="en-US" dirty="0"/>
-              <a:t>Considering that padding has recorded reduced performance in both the cycks model and the modified VGG model, the study agrees with </a:t>
+              <a:t>Considering that padding has recorded reduced performance in both the </a:t>
+            </a:r>
+            <a:r>
+              <a:rPr lang="en-US" dirty="0" err="1"/>
+              <a:t>cycks</a:t>
+            </a:r>
+            <a:r>
+              <a:rPr lang="en-US" dirty="0"/>
+              <a:t> model and the modified VGG model, the study agrees with </a:t>
             </a:r>
             <a:r>
               <a:rPr lang="en-US" dirty="0">
@@ -19311,7 +19361,13 @@
           <a:p>
             <a:r>
               <a:rPr lang="en-US" dirty="0"/>
-              <a:t>This calls for further research. Perhaps padding is only required on the initial layers or later layer of a convolution neural network to avoid what Alsallakh et al. (2021) call the spatial bias.</a:t>
+              <a:t>This calls for further research. Perhaps padding is only required on the initial layers or later layers of a convolution neural network to avoid what Alsallakh et al. (2021) call the spatial bias.</a:t>
+            </a:r>
+          </a:p>
+          <a:p>
+            <a:r>
+              <a:rPr lang="en-US" dirty="0"/>
+              <a:t>Indeed, hyper parameter tuning could have an effect the performance of convolution neural networks. Thus, examining how hyperparameters like batch normalization, strides, pooling,</a:t>
             </a:r>
           </a:p>
         </p:txBody>
@@ -19513,18 +19569,11 @@
               </a:lnSpc>
             </a:pPr>
             <a:r>
-              <a:rPr lang="en-US" sz="1800" dirty="0" err="1">
+              <a:rPr lang="en-US" sz="1800" dirty="0">
                 <a:latin typeface="Times New Roman" panose="02020603050405020304" pitchFamily="18" charset="0"/>
                 <a:cs typeface="Times New Roman" panose="02020603050405020304" pitchFamily="18" charset="0"/>
               </a:rPr>
-              <a:t>Astawa</a:t>
-            </a:r>
-            <a:r>
-              <a:rPr lang="en-US" sz="1800" dirty="0">
-                <a:latin typeface="Times New Roman" panose="02020603050405020304" pitchFamily="18" charset="0"/>
-                <a:cs typeface="Times New Roman" panose="02020603050405020304" pitchFamily="18" charset="0"/>
-              </a:rPr>
-              <a:t>, I. N. G. A., Putra, I. K. G. D., </a:t>
+              <a:t>Astawa, I. N. G. A., Putra, I. K. G. D., </a:t>
             </a:r>
             <a:r>
               <a:rPr lang="en-US" sz="1800" dirty="0" err="1">
@@ -19912,14 +19961,19 @@
             <p:ph type="title"/>
           </p:nvPr>
         </p:nvSpPr>
-        <p:spPr/>
+        <p:spPr>
+          <a:xfrm>
+            <a:off x="626446" y="295728"/>
+            <a:ext cx="9404723" cy="767687"/>
+          </a:xfrm>
+        </p:spPr>
         <p:txBody>
           <a:bodyPr/>
           <a:lstStyle/>
           <a:p>
             <a:r>
               <a:rPr lang="en-US" dirty="0"/>
-              <a:t>References</a:t>
+              <a:t>Selected References</a:t>
             </a:r>
             <a:endParaRPr lang="en-KE" dirty="0"/>
           </a:p>
@@ -20207,7 +20261,7 @@
           <p:cNvPr id="2" name="Title 1">
             <a:extLst>
               <a:ext uri="{FF2B5EF4-FFF2-40B4-BE49-F238E27FC236}">
-                <a16:creationId xmlns:a16="http://schemas.microsoft.com/office/drawing/2014/main" id="{01F6302F-7A93-7E5C-DFF7-8CE8F827D901}"/>
+                <a16:creationId xmlns:a16="http://schemas.microsoft.com/office/drawing/2014/main" id="{C21F1A38-D6BE-C9CA-465E-2D1F5A250B17}"/>
               </a:ext>
             </a:extLst>
           </p:cNvPr>
@@ -20223,11 +20277,37 @@
           <a:bodyPr/>
           <a:lstStyle/>
           <a:p>
-            <a:r>
-              <a:rPr lang="en-US" dirty="0"/>
-              <a:t>Workplan</a:t>
-            </a:r>
-            <a:endParaRPr lang="en-KE" dirty="0"/>
+            <a:endParaRPr lang="en-US" dirty="0"/>
+          </a:p>
+        </p:txBody>
+      </p:sp>
+      <p:sp>
+        <p:nvSpPr>
+          <p:cNvPr id="3" name="Content Placeholder 2">
+            <a:extLst>
+              <a:ext uri="{FF2B5EF4-FFF2-40B4-BE49-F238E27FC236}">
+                <a16:creationId xmlns:a16="http://schemas.microsoft.com/office/drawing/2014/main" id="{C702F44A-D389-7A74-C665-E41F74D31D7E}"/>
+              </a:ext>
+            </a:extLst>
+          </p:cNvPr>
+          <p:cNvSpPr>
+            <a:spLocks noGrp="1"/>
+          </p:cNvSpPr>
+          <p:nvPr>
+            <p:ph idx="1"/>
+          </p:nvPr>
+        </p:nvSpPr>
+        <p:spPr/>
+        <p:txBody>
+          <a:bodyPr>
+            <a:normAutofit/>
+          </a:bodyPr>
+          <a:lstStyle/>
+          <a:p>
+            <a:r>
+              <a:rPr lang="en-US" sz="7200" dirty="0"/>
+              <a:t>Thank You</a:t>
+            </a:r>
           </a:p>
         </p:txBody>
       </p:sp>
@@ -20236,7 +20316,7 @@
           <p:cNvPr id="4" name="Slide Number Placeholder 3">
             <a:extLst>
               <a:ext uri="{FF2B5EF4-FFF2-40B4-BE49-F238E27FC236}">
-                <a16:creationId xmlns:a16="http://schemas.microsoft.com/office/drawing/2014/main" id="{FA20ACF8-8A94-7FF7-3CF4-6837F006E62A}"/>
+                <a16:creationId xmlns:a16="http://schemas.microsoft.com/office/drawing/2014/main" id="{AF222662-70C0-5E87-158E-DE8C36AC8D1A}"/>
               </a:ext>
             </a:extLst>
           </p:cNvPr>
@@ -20260,45 +20340,10 @@
           </a:p>
         </p:txBody>
       </p:sp>
-      <p:pic>
-        <p:nvPicPr>
-          <p:cNvPr id="7" name="Content Placeholder 6">
-            <a:extLst>
-              <a:ext uri="{FF2B5EF4-FFF2-40B4-BE49-F238E27FC236}">
-                <a16:creationId xmlns:a16="http://schemas.microsoft.com/office/drawing/2014/main" id="{FB32EBF9-E750-C5C2-8A95-E0F7C44FFF02}"/>
-              </a:ext>
-            </a:extLst>
-          </p:cNvPr>
-          <p:cNvPicPr>
-            <a:picLocks noGrp="1" noChangeAspect="1"/>
-          </p:cNvPicPr>
-          <p:nvPr>
-            <p:ph idx="1"/>
-          </p:nvPr>
-        </p:nvPicPr>
-        <p:blipFill>
-          <a:blip r:embed="rId2">
-            <a:extLst>
-              <a:ext uri="{28A0092B-C50C-407E-A947-70E740481C1C}">
-                <a14:useLocalDpi xmlns:a14="http://schemas.microsoft.com/office/drawing/2010/main" val="0"/>
-              </a:ext>
-            </a:extLst>
-          </a:blip>
-          <a:stretch>
-            <a:fillRect/>
-          </a:stretch>
-        </p:blipFill>
-        <p:spPr>
-          <a:xfrm>
-            <a:off x="1095905" y="1372409"/>
-            <a:ext cx="9574135" cy="5189862"/>
-          </a:xfrm>
-        </p:spPr>
-      </p:pic>
     </p:spTree>
     <p:extLst>
       <p:ext uri="{BB962C8B-B14F-4D97-AF65-F5344CB8AC3E}">
-        <p14:creationId xmlns:p14="http://schemas.microsoft.com/office/powerpoint/2010/main" val="3639756175"/>
+        <p14:creationId xmlns:p14="http://schemas.microsoft.com/office/powerpoint/2010/main" val="168842785"/>
       </p:ext>
     </p:extLst>
   </p:cSld>
@@ -20467,617 +20512,6 @@
     <p:extLst>
       <p:ext uri="{BB962C8B-B14F-4D97-AF65-F5344CB8AC3E}">
         <p14:creationId xmlns:p14="http://schemas.microsoft.com/office/powerpoint/2010/main" val="3240247130"/>
-      </p:ext>
-    </p:extLst>
-  </p:cSld>
-  <p:clrMapOvr>
-    <a:masterClrMapping/>
-  </p:clrMapOvr>
-</p:sld>
-</file>
-
-<file path=ppt/slides/slide40.xml><?xml version="1.0" encoding="utf-8"?>
-<p:sld xmlns:a="http://schemas.openxmlformats.org/drawingml/2006/main" xmlns:r="http://schemas.openxmlformats.org/officeDocument/2006/relationships" xmlns:p="http://schemas.openxmlformats.org/presentationml/2006/main">
-  <p:cSld>
-    <p:spTree>
-      <p:nvGrpSpPr>
-        <p:cNvPr id="1" name=""/>
-        <p:cNvGrpSpPr/>
-        <p:nvPr/>
-      </p:nvGrpSpPr>
-      <p:grpSpPr>
-        <a:xfrm>
-          <a:off x="0" y="0"/>
-          <a:ext cx="0" cy="0"/>
-          <a:chOff x="0" y="0"/>
-          <a:chExt cx="0" cy="0"/>
-        </a:xfrm>
-      </p:grpSpPr>
-      <p:sp>
-        <p:nvSpPr>
-          <p:cNvPr id="2" name="Title 1">
-            <a:extLst>
-              <a:ext uri="{FF2B5EF4-FFF2-40B4-BE49-F238E27FC236}">
-                <a16:creationId xmlns:a16="http://schemas.microsoft.com/office/drawing/2014/main" id="{645A70BA-7371-5872-9772-8DF8A47E22F9}"/>
-              </a:ext>
-            </a:extLst>
-          </p:cNvPr>
-          <p:cNvSpPr>
-            <a:spLocks noGrp="1"/>
-          </p:cNvSpPr>
-          <p:nvPr>
-            <p:ph type="title"/>
-          </p:nvPr>
-        </p:nvSpPr>
-        <p:spPr/>
-        <p:txBody>
-          <a:bodyPr/>
-          <a:lstStyle/>
-          <a:p>
-            <a:r>
-              <a:rPr lang="en-US" dirty="0"/>
-              <a:t>Budget</a:t>
-            </a:r>
-            <a:endParaRPr lang="en-KE" dirty="0"/>
-          </a:p>
-        </p:txBody>
-      </p:sp>
-      <p:graphicFrame>
-        <p:nvGraphicFramePr>
-          <p:cNvPr id="5" name="Content Placeholder 4">
-            <a:extLst>
-              <a:ext uri="{FF2B5EF4-FFF2-40B4-BE49-F238E27FC236}">
-                <a16:creationId xmlns:a16="http://schemas.microsoft.com/office/drawing/2014/main" id="{4D4F66AE-B1FB-989A-76AD-F34CAB75098C}"/>
-              </a:ext>
-            </a:extLst>
-          </p:cNvPr>
-          <p:cNvGraphicFramePr>
-            <a:graphicFrameLocks noGrp="1"/>
-          </p:cNvGraphicFramePr>
-          <p:nvPr>
-            <p:ph idx="1"/>
-            <p:extLst>
-              <p:ext uri="{D42A27DB-BD31-4B8C-83A1-F6EECF244321}">
-                <p14:modId xmlns:p14="http://schemas.microsoft.com/office/powerpoint/2010/main" val="1659249931"/>
-              </p:ext>
-            </p:extLst>
-          </p:nvPr>
-        </p:nvGraphicFramePr>
-        <p:xfrm>
-          <a:off x="1409700" y="2311400"/>
-          <a:ext cx="9042400" cy="3517900"/>
-        </p:xfrm>
-        <a:graphic>
-          <a:graphicData uri="http://schemas.openxmlformats.org/drawingml/2006/table">
-            <a:tbl>
-              <a:tblPr firstRow="1" firstCol="1" bandRow="1">
-                <a:tableStyleId>{5C22544A-7EE6-4342-B048-85BDC9FD1C3A}</a:tableStyleId>
-              </a:tblPr>
-              <a:tblGrid>
-                <a:gridCol w="4228733">
-                  <a:extLst>
-                    <a:ext uri="{9D8B030D-6E8A-4147-A177-3AD203B41FA5}">
-                      <a16:colId xmlns:a16="http://schemas.microsoft.com/office/drawing/2014/main" val="3568868473"/>
-                    </a:ext>
-                  </a:extLst>
-                </a:gridCol>
-                <a:gridCol w="1215444">
-                  <a:extLst>
-                    <a:ext uri="{9D8B030D-6E8A-4147-A177-3AD203B41FA5}">
-                      <a16:colId xmlns:a16="http://schemas.microsoft.com/office/drawing/2014/main" val="1504280108"/>
-                    </a:ext>
-                  </a:extLst>
-                </a:gridCol>
-                <a:gridCol w="2048531">
-                  <a:extLst>
-                    <a:ext uri="{9D8B030D-6E8A-4147-A177-3AD203B41FA5}">
-                      <a16:colId xmlns:a16="http://schemas.microsoft.com/office/drawing/2014/main" val="3260370623"/>
-                    </a:ext>
-                  </a:extLst>
-                </a:gridCol>
-                <a:gridCol w="1549692">
-                  <a:extLst>
-                    <a:ext uri="{9D8B030D-6E8A-4147-A177-3AD203B41FA5}">
-                      <a16:colId xmlns:a16="http://schemas.microsoft.com/office/drawing/2014/main" val="1030405989"/>
-                    </a:ext>
-                  </a:extLst>
-                </a:gridCol>
-              </a:tblGrid>
-              <a:tr h="703580">
-                <a:tc>
-                  <a:txBody>
-                    <a:bodyPr/>
-                    <a:lstStyle/>
-                    <a:p>
-                      <a:r>
-                        <a:rPr lang="en-KE" sz="1800" kern="0" dirty="0">
-                          <a:effectLst/>
-                        </a:rPr>
-                        <a:t>Description</a:t>
-                      </a:r>
-                      <a:endParaRPr lang="en-KE" sz="1800" kern="100" dirty="0">
-                        <a:effectLst/>
-                        <a:latin typeface="Liberation Serif"/>
-                        <a:ea typeface="Noto Serif CJK SC"/>
-                        <a:cs typeface="Lohit Devanagari"/>
-                      </a:endParaRPr>
-                    </a:p>
-                  </a:txBody>
-                  <a:tcPr marL="68580" marR="68580" marT="0" marB="0" anchor="b"/>
-                </a:tc>
-                <a:tc>
-                  <a:txBody>
-                    <a:bodyPr/>
-                    <a:lstStyle/>
-                    <a:p>
-                      <a:r>
-                        <a:rPr lang="en-KE" sz="1800" kern="0">
-                          <a:effectLst/>
-                        </a:rPr>
-                        <a:t>Item </a:t>
-                      </a:r>
-                      <a:endParaRPr lang="en-KE" sz="1800" kern="100">
-                        <a:effectLst/>
-                        <a:latin typeface="Liberation Serif"/>
-                        <a:ea typeface="Noto Serif CJK SC"/>
-                        <a:cs typeface="Lohit Devanagari"/>
-                      </a:endParaRPr>
-                    </a:p>
-                  </a:txBody>
-                  <a:tcPr marL="68580" marR="68580" marT="0" marB="0" anchor="b"/>
-                </a:tc>
-                <a:tc>
-                  <a:txBody>
-                    <a:bodyPr/>
-                    <a:lstStyle/>
-                    <a:p>
-                      <a:r>
-                        <a:rPr lang="en-KE" sz="1800" kern="0">
-                          <a:effectLst/>
-                        </a:rPr>
-                        <a:t>Unit Costs</a:t>
-                      </a:r>
-                      <a:endParaRPr lang="en-KE" sz="1800" kern="100">
-                        <a:effectLst/>
-                        <a:latin typeface="Liberation Serif"/>
-                        <a:ea typeface="Noto Serif CJK SC"/>
-                        <a:cs typeface="Lohit Devanagari"/>
-                      </a:endParaRPr>
-                    </a:p>
-                  </a:txBody>
-                  <a:tcPr marL="68580" marR="68580" marT="0" marB="0" anchor="b"/>
-                </a:tc>
-                <a:tc>
-                  <a:txBody>
-                    <a:bodyPr/>
-                    <a:lstStyle/>
-                    <a:p>
-                      <a:r>
-                        <a:rPr lang="en-KE" sz="1800" kern="0">
-                          <a:effectLst/>
-                        </a:rPr>
-                        <a:t>Total Costs</a:t>
-                      </a:r>
-                      <a:endParaRPr lang="en-KE" sz="1800" kern="100">
-                        <a:effectLst/>
-                        <a:latin typeface="Liberation Serif"/>
-                        <a:ea typeface="Noto Serif CJK SC"/>
-                        <a:cs typeface="Lohit Devanagari"/>
-                      </a:endParaRPr>
-                    </a:p>
-                  </a:txBody>
-                  <a:tcPr marL="68580" marR="68580" marT="0" marB="0" anchor="b"/>
-                </a:tc>
-                <a:extLst>
-                  <a:ext uri="{0D108BD9-81ED-4DB2-BD59-A6C34878D82A}">
-                    <a16:rowId xmlns:a16="http://schemas.microsoft.com/office/drawing/2014/main" val="1622482460"/>
-                  </a:ext>
-                </a:extLst>
-              </a:tr>
-              <a:tr h="703580">
-                <a:tc>
-                  <a:txBody>
-                    <a:bodyPr/>
-                    <a:lstStyle/>
-                    <a:p>
-                      <a:r>
-                        <a:rPr lang="en-KE" sz="1800" kern="0" dirty="0">
-                          <a:effectLst/>
-                        </a:rPr>
-                        <a:t>Internet Costs</a:t>
-                      </a:r>
-                      <a:endParaRPr lang="en-KE" sz="1800" kern="100" dirty="0">
-                        <a:effectLst/>
-                        <a:latin typeface="Liberation Serif"/>
-                        <a:ea typeface="Noto Serif CJK SC"/>
-                        <a:cs typeface="Lohit Devanagari"/>
-                      </a:endParaRPr>
-                    </a:p>
-                  </a:txBody>
-                  <a:tcPr marL="68580" marR="68580" marT="0" marB="0" anchor="b"/>
-                </a:tc>
-                <a:tc>
-                  <a:txBody>
-                    <a:bodyPr/>
-                    <a:lstStyle/>
-                    <a:p>
-                      <a:pPr algn="r"/>
-                      <a:r>
-                        <a:rPr lang="en-KE" sz="1800" kern="0" dirty="0">
-                          <a:effectLst/>
-                        </a:rPr>
-                        <a:t>1</a:t>
-                      </a:r>
-                      <a:endParaRPr lang="en-KE" sz="1800" kern="100" dirty="0">
-                        <a:effectLst/>
-                        <a:latin typeface="Liberation Serif"/>
-                        <a:ea typeface="Noto Serif CJK SC"/>
-                        <a:cs typeface="Lohit Devanagari"/>
-                      </a:endParaRPr>
-                    </a:p>
-                  </a:txBody>
-                  <a:tcPr marL="68580" marR="68580" marT="0" marB="0" anchor="b"/>
-                </a:tc>
-                <a:tc>
-                  <a:txBody>
-                    <a:bodyPr/>
-                    <a:lstStyle/>
-                    <a:p>
-                      <a:r>
-                        <a:rPr lang="en-KE" sz="1800" kern="0">
-                          <a:effectLst/>
-                        </a:rPr>
-                        <a:t>                3,000.00 </a:t>
-                      </a:r>
-                      <a:endParaRPr lang="en-KE" sz="1800" kern="100">
-                        <a:effectLst/>
-                        <a:latin typeface="Liberation Serif"/>
-                        <a:ea typeface="Noto Serif CJK SC"/>
-                        <a:cs typeface="Lohit Devanagari"/>
-                      </a:endParaRPr>
-                    </a:p>
-                  </a:txBody>
-                  <a:tcPr marL="68580" marR="68580" marT="0" marB="0" anchor="b"/>
-                </a:tc>
-                <a:tc>
-                  <a:txBody>
-                    <a:bodyPr/>
-                    <a:lstStyle/>
-                    <a:p>
-                      <a:r>
-                        <a:rPr lang="en-KE" sz="1800" kern="0">
-                          <a:effectLst/>
-                        </a:rPr>
-                        <a:t>       3,000.00 </a:t>
-                      </a:r>
-                      <a:endParaRPr lang="en-KE" sz="1800" kern="100">
-                        <a:effectLst/>
-                        <a:latin typeface="Liberation Serif"/>
-                        <a:ea typeface="Noto Serif CJK SC"/>
-                        <a:cs typeface="Lohit Devanagari"/>
-                      </a:endParaRPr>
-                    </a:p>
-                  </a:txBody>
-                  <a:tcPr marL="68580" marR="68580" marT="0" marB="0" anchor="b"/>
-                </a:tc>
-                <a:extLst>
-                  <a:ext uri="{0D108BD9-81ED-4DB2-BD59-A6C34878D82A}">
-                    <a16:rowId xmlns:a16="http://schemas.microsoft.com/office/drawing/2014/main" val="3382214317"/>
-                  </a:ext>
-                </a:extLst>
-              </a:tr>
-              <a:tr h="703580">
-                <a:tc>
-                  <a:txBody>
-                    <a:bodyPr/>
-                    <a:lstStyle/>
-                    <a:p>
-                      <a:r>
-                        <a:rPr lang="en-KE" sz="1800" kern="0">
-                          <a:effectLst/>
-                        </a:rPr>
-                        <a:t>Payment for Data Collectors</a:t>
-                      </a:r>
-                      <a:endParaRPr lang="en-KE" sz="1800" kern="100">
-                        <a:effectLst/>
-                        <a:latin typeface="Liberation Serif"/>
-                        <a:ea typeface="Noto Serif CJK SC"/>
-                        <a:cs typeface="Lohit Devanagari"/>
-                      </a:endParaRPr>
-                    </a:p>
-                  </a:txBody>
-                  <a:tcPr marL="68580" marR="68580" marT="0" marB="0" anchor="b"/>
-                </a:tc>
-                <a:tc>
-                  <a:txBody>
-                    <a:bodyPr/>
-                    <a:lstStyle/>
-                    <a:p>
-                      <a:pPr algn="r"/>
-                      <a:r>
-                        <a:rPr lang="en-KE" sz="1800" kern="0">
-                          <a:effectLst/>
-                        </a:rPr>
-                        <a:t>3</a:t>
-                      </a:r>
-                      <a:endParaRPr lang="en-KE" sz="1800" kern="100">
-                        <a:effectLst/>
-                        <a:latin typeface="Liberation Serif"/>
-                        <a:ea typeface="Noto Serif CJK SC"/>
-                        <a:cs typeface="Lohit Devanagari"/>
-                      </a:endParaRPr>
-                    </a:p>
-                  </a:txBody>
-                  <a:tcPr marL="68580" marR="68580" marT="0" marB="0" anchor="b"/>
-                </a:tc>
-                <a:tc>
-                  <a:txBody>
-                    <a:bodyPr/>
-                    <a:lstStyle/>
-                    <a:p>
-                      <a:r>
-                        <a:rPr lang="en-KE" sz="1800" kern="0" dirty="0">
-                          <a:effectLst/>
-                        </a:rPr>
-                        <a:t>              15,000.00 </a:t>
-                      </a:r>
-                      <a:endParaRPr lang="en-KE" sz="1800" kern="100" dirty="0">
-                        <a:effectLst/>
-                        <a:latin typeface="Liberation Serif"/>
-                        <a:ea typeface="Noto Serif CJK SC"/>
-                        <a:cs typeface="Lohit Devanagari"/>
-                      </a:endParaRPr>
-                    </a:p>
-                  </a:txBody>
-                  <a:tcPr marL="68580" marR="68580" marT="0" marB="0" anchor="b"/>
-                </a:tc>
-                <a:tc>
-                  <a:txBody>
-                    <a:bodyPr/>
-                    <a:lstStyle/>
-                    <a:p>
-                      <a:r>
-                        <a:rPr lang="en-KE" sz="1800" kern="0" dirty="0">
-                          <a:effectLst/>
-                        </a:rPr>
-                        <a:t>     45,000.00 </a:t>
-                      </a:r>
-                      <a:endParaRPr lang="en-KE" sz="1800" kern="100" dirty="0">
-                        <a:effectLst/>
-                        <a:latin typeface="Liberation Serif"/>
-                        <a:ea typeface="Noto Serif CJK SC"/>
-                        <a:cs typeface="Lohit Devanagari"/>
-                      </a:endParaRPr>
-                    </a:p>
-                  </a:txBody>
-                  <a:tcPr marL="68580" marR="68580" marT="0" marB="0" anchor="b"/>
-                </a:tc>
-                <a:extLst>
-                  <a:ext uri="{0D108BD9-81ED-4DB2-BD59-A6C34878D82A}">
-                    <a16:rowId xmlns:a16="http://schemas.microsoft.com/office/drawing/2014/main" val="547562982"/>
-                  </a:ext>
-                </a:extLst>
-              </a:tr>
-              <a:tr h="703580">
-                <a:tc>
-                  <a:txBody>
-                    <a:bodyPr/>
-                    <a:lstStyle/>
-                    <a:p>
-                      <a:r>
-                        <a:rPr lang="en-KE" sz="1800" kern="0">
-                          <a:effectLst/>
-                        </a:rPr>
-                        <a:t>Printing Reports</a:t>
-                      </a:r>
-                      <a:endParaRPr lang="en-KE" sz="1800" kern="100">
-                        <a:effectLst/>
-                        <a:latin typeface="Liberation Serif"/>
-                        <a:ea typeface="Noto Serif CJK SC"/>
-                        <a:cs typeface="Lohit Devanagari"/>
-                      </a:endParaRPr>
-                    </a:p>
-                  </a:txBody>
-                  <a:tcPr marL="68580" marR="68580" marT="0" marB="0" anchor="b"/>
-                </a:tc>
-                <a:tc>
-                  <a:txBody>
-                    <a:bodyPr/>
-                    <a:lstStyle/>
-                    <a:p>
-                      <a:pPr algn="r"/>
-                      <a:r>
-                        <a:rPr lang="en-KE" sz="1800" kern="0">
-                          <a:effectLst/>
-                        </a:rPr>
-                        <a:t>2</a:t>
-                      </a:r>
-                      <a:endParaRPr lang="en-KE" sz="1800" kern="100">
-                        <a:effectLst/>
-                        <a:latin typeface="Liberation Serif"/>
-                        <a:ea typeface="Noto Serif CJK SC"/>
-                        <a:cs typeface="Lohit Devanagari"/>
-                      </a:endParaRPr>
-                    </a:p>
-                  </a:txBody>
-                  <a:tcPr marL="68580" marR="68580" marT="0" marB="0" anchor="b"/>
-                </a:tc>
-                <a:tc>
-                  <a:txBody>
-                    <a:bodyPr/>
-                    <a:lstStyle/>
-                    <a:p>
-                      <a:r>
-                        <a:rPr lang="en-KE" sz="1800" kern="0">
-                          <a:effectLst/>
-                        </a:rPr>
-                        <a:t>                2,000.00 </a:t>
-                      </a:r>
-                      <a:endParaRPr lang="en-KE" sz="1800" kern="100">
-                        <a:effectLst/>
-                        <a:latin typeface="Liberation Serif"/>
-                        <a:ea typeface="Noto Serif CJK SC"/>
-                        <a:cs typeface="Lohit Devanagari"/>
-                      </a:endParaRPr>
-                    </a:p>
-                  </a:txBody>
-                  <a:tcPr marL="68580" marR="68580" marT="0" marB="0" anchor="b"/>
-                </a:tc>
-                <a:tc>
-                  <a:txBody>
-                    <a:bodyPr/>
-                    <a:lstStyle/>
-                    <a:p>
-                      <a:r>
-                        <a:rPr lang="en-KE" sz="1800" kern="0" dirty="0">
-                          <a:effectLst/>
-                        </a:rPr>
-                        <a:t>       2,000.00 </a:t>
-                      </a:r>
-                      <a:endParaRPr lang="en-KE" sz="1800" kern="100" dirty="0">
-                        <a:effectLst/>
-                        <a:latin typeface="Liberation Serif"/>
-                        <a:ea typeface="Noto Serif CJK SC"/>
-                        <a:cs typeface="Lohit Devanagari"/>
-                      </a:endParaRPr>
-                    </a:p>
-                  </a:txBody>
-                  <a:tcPr marL="68580" marR="68580" marT="0" marB="0" anchor="b"/>
-                </a:tc>
-                <a:extLst>
-                  <a:ext uri="{0D108BD9-81ED-4DB2-BD59-A6C34878D82A}">
-                    <a16:rowId xmlns:a16="http://schemas.microsoft.com/office/drawing/2014/main" val="3995225901"/>
-                  </a:ext>
-                </a:extLst>
-              </a:tr>
-              <a:tr h="703580">
-                <a:tc>
-                  <a:txBody>
-                    <a:bodyPr/>
-                    <a:lstStyle/>
-                    <a:p>
-                      <a:r>
-                        <a:rPr lang="en-KE" sz="1800" kern="0">
-                          <a:effectLst/>
-                        </a:rPr>
-                        <a:t>Grand Total</a:t>
-                      </a:r>
-                      <a:endParaRPr lang="en-KE" sz="1800" kern="100">
-                        <a:effectLst/>
-                        <a:latin typeface="Liberation Serif"/>
-                        <a:ea typeface="Noto Serif CJK SC"/>
-                        <a:cs typeface="Lohit Devanagari"/>
-                      </a:endParaRPr>
-                    </a:p>
-                  </a:txBody>
-                  <a:tcPr marL="68580" marR="68580" marT="0" marB="0" anchor="b"/>
-                </a:tc>
-                <a:tc>
-                  <a:txBody>
-                    <a:bodyPr/>
-                    <a:lstStyle/>
-                    <a:p>
-                      <a:r>
-                        <a:rPr lang="en-KE" sz="1800" kern="0">
-                          <a:effectLst/>
-                        </a:rPr>
-                        <a:t> </a:t>
-                      </a:r>
-                      <a:endParaRPr lang="en-KE" sz="1800" kern="100">
-                        <a:effectLst/>
-                        <a:latin typeface="Liberation Serif"/>
-                        <a:ea typeface="Noto Serif CJK SC"/>
-                        <a:cs typeface="Lohit Devanagari"/>
-                      </a:endParaRPr>
-                    </a:p>
-                  </a:txBody>
-                  <a:tcPr marL="68580" marR="68580" marT="0" marB="0" anchor="b"/>
-                </a:tc>
-                <a:tc>
-                  <a:txBody>
-                    <a:bodyPr/>
-                    <a:lstStyle/>
-                    <a:p>
-                      <a:r>
-                        <a:rPr lang="en-KE" sz="1800" kern="0">
-                          <a:effectLst/>
-                        </a:rPr>
-                        <a:t> </a:t>
-                      </a:r>
-                      <a:endParaRPr lang="en-KE" sz="1800" kern="100">
-                        <a:effectLst/>
-                        <a:latin typeface="Liberation Serif"/>
-                        <a:ea typeface="Noto Serif CJK SC"/>
-                        <a:cs typeface="Lohit Devanagari"/>
-                      </a:endParaRPr>
-                    </a:p>
-                  </a:txBody>
-                  <a:tcPr marL="68580" marR="68580" marT="0" marB="0" anchor="b"/>
-                </a:tc>
-                <a:tc>
-                  <a:txBody>
-                    <a:bodyPr/>
-                    <a:lstStyle/>
-                    <a:p>
-                      <a:r>
-                        <a:rPr lang="en-KE" sz="1800" kern="0" dirty="0">
-                          <a:effectLst/>
-                        </a:rPr>
-                        <a:t>   50,000.00 </a:t>
-                      </a:r>
-                      <a:endParaRPr lang="en-KE" sz="1800" kern="100" dirty="0">
-                        <a:effectLst/>
-                        <a:latin typeface="Liberation Serif"/>
-                        <a:ea typeface="Noto Serif CJK SC"/>
-                        <a:cs typeface="Lohit Devanagari"/>
-                      </a:endParaRPr>
-                    </a:p>
-                  </a:txBody>
-                  <a:tcPr marL="68580" marR="68580" marT="0" marB="0" anchor="b"/>
-                </a:tc>
-                <a:extLst>
-                  <a:ext uri="{0D108BD9-81ED-4DB2-BD59-A6C34878D82A}">
-                    <a16:rowId xmlns:a16="http://schemas.microsoft.com/office/drawing/2014/main" val="4219016017"/>
-                  </a:ext>
-                </a:extLst>
-              </a:tr>
-            </a:tbl>
-          </a:graphicData>
-        </a:graphic>
-      </p:graphicFrame>
-      <p:sp>
-        <p:nvSpPr>
-          <p:cNvPr id="4" name="Slide Number Placeholder 3">
-            <a:extLst>
-              <a:ext uri="{FF2B5EF4-FFF2-40B4-BE49-F238E27FC236}">
-                <a16:creationId xmlns:a16="http://schemas.microsoft.com/office/drawing/2014/main" id="{D00FDB8D-10CC-31D5-68A6-9BA511EC8214}"/>
-              </a:ext>
-            </a:extLst>
-          </p:cNvPr>
-          <p:cNvSpPr>
-            <a:spLocks noGrp="1"/>
-          </p:cNvSpPr>
-          <p:nvPr>
-            <p:ph type="sldNum" sz="quarter" idx="12"/>
-          </p:nvPr>
-        </p:nvSpPr>
-        <p:spPr/>
-        <p:txBody>
-          <a:bodyPr/>
-          <a:lstStyle/>
-          <a:p>
-            <a:fld id="{A755A77B-A17B-45F4-84E2-294C20E72625}" type="slidenum">
-              <a:rPr lang="en-KE" smtClean="0"/>
-              <a:t>40</a:t>
-            </a:fld>
-            <a:endParaRPr lang="en-KE"/>
-          </a:p>
-        </p:txBody>
-      </p:sp>
-    </p:spTree>
-    <p:extLst>
-      <p:ext uri="{BB962C8B-B14F-4D97-AF65-F5344CB8AC3E}">
-        <p14:creationId xmlns:p14="http://schemas.microsoft.com/office/powerpoint/2010/main" val="1003903782"/>
       </p:ext>
     </p:extLst>
   </p:cSld>

</xml_diff>

<commit_message>
work upto block five
</commit_message>
<xml_diff>
--- a/mydocuments/Examining The Effect of Padding on Facial Recognition.pptx
+++ b/mydocuments/Examining The Effect of Padding on Facial Recognition.pptx
@@ -6698,6 +6698,16 @@
           </a:p>
           <a:p>
             <a:r>
+              <a:rPr lang="en-US" dirty="0" err="1">
+                <a:solidFill>
+                  <a:schemeClr val="accent3">
+                    <a:lumMod val="75000"/>
+                  </a:schemeClr>
+                </a:solidFill>
+              </a:rPr>
+              <a:t>MArch</a:t>
+            </a:r>
+            <a:r>
               <a:rPr lang="en-US" dirty="0">
                 <a:solidFill>
                   <a:schemeClr val="accent3">
@@ -6705,7 +6715,7 @@
                   </a:schemeClr>
                 </a:solidFill>
               </a:rPr>
-              <a:t>January 28 2025</a:t>
+              <a:t> 26 2026</a:t>
             </a:r>
             <a:endParaRPr lang="en-KE" dirty="0">
               <a:solidFill>
@@ -20463,7 +20473,7 @@
                 <a:latin typeface="Times New Roman" panose="02020603050405020304" pitchFamily="18" charset="0"/>
                 <a:ea typeface="Noto Serif CJK SC"/>
               </a:rPr>
-              <a:t>While the mentioned authors have touched on the effect of padding on neural networks, no study was found examining the effect of padding on convolution neural networks.</a:t>
+              <a:t>While the mentioned authors have touched on the effect of padding on neural networks, no study was found examining the effect of padding on convolution neural networks and facial recognition.</a:t>
             </a:r>
           </a:p>
           <a:p>

</xml_diff>